<commit_message>
Briefing específico dos mesários: mesmos slides de encerramento
Aplica ao deck enviado a main (2026.09.23_Mesarios_Briefing_v2) as
mesmas atualizações do briefing da equipe: agenda com o 7º item
"Encerramento" e os slides 15 ("Cinco passos para fechar a seção") e 16
("Ninguém sai antes da conferência"), antes do checklist final.
Resultado em Apresentações/2026.10.21_Mesarios_Briefing_v3.pptx.

O gerador passa a localizar os cartões da agenda pela posição, não pelo
nome das formas, e reduz a descrição dos cartões a 10 pt, porque o deck
dos mesários usa 11,5 pt e estourava os cartões mais estreitos. O
briefing da equipe foi regerado com o mesmo ajuste.

Co-Authored-By: Claude Opus 5.5 <noreply@anthropic.com>
Claude-Session: https://claude.ai/code/session_014eSxMAzk36ZK9tfxT5H1nB
</commit_message>
<xml_diff>
--- a/Apresentações/2026.10.19_Equipe Embaixada_Briefing.pptx
+++ b/Apresentações/2026.10.19_Equipe Embaixada_Briefing.pptx
@@ -20666,8 +20666,8 @@
         </p:nvSpPr>
         <p:spPr>
           <a:xfrm>
-            <a:off x="566928" y="2103120"/>
-            <a:ext cx="2558034" cy="1883664"/>
+            <a:off x="566928" y="1920240"/>
+            <a:ext cx="2558034" cy="2011680"/>
           </a:xfrm>
           <a:prstGeom prst="roundRect">
             <a:avLst>
@@ -20700,7 +20700,7 @@
         </p:nvSpPr>
         <p:spPr>
           <a:xfrm>
-            <a:off x="877824" y="2414015"/>
+            <a:off x="877824" y="2231136"/>
             <a:ext cx="310896" cy="310896"/>
           </a:xfrm>
           <a:prstGeom prst="ellipse">
@@ -20727,7 +20727,7 @@
         </p:nvSpPr>
         <p:spPr>
           <a:xfrm>
-            <a:off x="877824" y="2414015"/>
+            <a:off x="877824" y="2231136"/>
             <a:ext cx="310896" cy="310896"/>
           </a:xfrm>
           <a:prstGeom prst="rect">
@@ -20766,7 +20766,7 @@
         </p:nvSpPr>
         <p:spPr>
           <a:xfrm>
-            <a:off x="877824" y="2889503"/>
+            <a:off x="877824" y="2706624"/>
             <a:ext cx="1936241" cy="292608"/>
           </a:xfrm>
           <a:prstGeom prst="rect">
@@ -20805,8 +20805,8 @@
         </p:nvSpPr>
         <p:spPr>
           <a:xfrm>
-            <a:off x="877824" y="3236976"/>
-            <a:ext cx="1936241" cy="685800"/>
+            <a:off x="877824" y="3054096"/>
+            <a:ext cx="1936241" cy="731520"/>
           </a:xfrm>
           <a:prstGeom prst="rect">
             <a:avLst/>
@@ -20847,8 +20847,8 @@
         </p:nvSpPr>
         <p:spPr>
           <a:xfrm>
-            <a:off x="3399282" y="2103120"/>
-            <a:ext cx="2558034" cy="1883664"/>
+            <a:off x="3399282" y="1920240"/>
+            <a:ext cx="2558034" cy="2011680"/>
           </a:xfrm>
           <a:prstGeom prst="roundRect">
             <a:avLst>
@@ -20881,7 +20881,7 @@
         </p:nvSpPr>
         <p:spPr>
           <a:xfrm>
-            <a:off x="3710178" y="2414015"/>
+            <a:off x="3710178" y="2231136"/>
             <a:ext cx="310896" cy="310896"/>
           </a:xfrm>
           <a:prstGeom prst="ellipse">
@@ -20908,7 +20908,7 @@
         </p:nvSpPr>
         <p:spPr>
           <a:xfrm>
-            <a:off x="3710178" y="2414015"/>
+            <a:off x="3710178" y="2231136"/>
             <a:ext cx="310896" cy="310896"/>
           </a:xfrm>
           <a:prstGeom prst="rect">
@@ -20947,7 +20947,7 @@
         </p:nvSpPr>
         <p:spPr>
           <a:xfrm>
-            <a:off x="3710178" y="2889503"/>
+            <a:off x="3710178" y="2706624"/>
             <a:ext cx="1936241" cy="292608"/>
           </a:xfrm>
           <a:prstGeom prst="rect">
@@ -20986,8 +20986,8 @@
         </p:nvSpPr>
         <p:spPr>
           <a:xfrm>
-            <a:off x="3710178" y="3236976"/>
-            <a:ext cx="1936241" cy="685800"/>
+            <a:off x="3710178" y="3054096"/>
+            <a:ext cx="1936241" cy="731520"/>
           </a:xfrm>
           <a:prstGeom prst="rect">
             <a:avLst/>
@@ -21028,8 +21028,8 @@
         </p:nvSpPr>
         <p:spPr>
           <a:xfrm>
-            <a:off x="6231636" y="2103120"/>
-            <a:ext cx="2558034" cy="1883664"/>
+            <a:off x="6231636" y="1920240"/>
+            <a:ext cx="2558034" cy="2011680"/>
           </a:xfrm>
           <a:prstGeom prst="roundRect">
             <a:avLst>
@@ -21062,7 +21062,7 @@
         </p:nvSpPr>
         <p:spPr>
           <a:xfrm>
-            <a:off x="6542531" y="2414015"/>
+            <a:off x="6542531" y="2231136"/>
             <a:ext cx="310896" cy="310896"/>
           </a:xfrm>
           <a:prstGeom prst="ellipse">
@@ -21089,7 +21089,7 @@
         </p:nvSpPr>
         <p:spPr>
           <a:xfrm>
-            <a:off x="6542531" y="2414015"/>
+            <a:off x="6542531" y="2231136"/>
             <a:ext cx="310896" cy="310896"/>
           </a:xfrm>
           <a:prstGeom prst="rect">
@@ -21128,7 +21128,7 @@
         </p:nvSpPr>
         <p:spPr>
           <a:xfrm>
-            <a:off x="6542531" y="2889503"/>
+            <a:off x="6542531" y="2706624"/>
             <a:ext cx="1936241" cy="292608"/>
           </a:xfrm>
           <a:prstGeom prst="rect">
@@ -21167,8 +21167,8 @@
         </p:nvSpPr>
         <p:spPr>
           <a:xfrm>
-            <a:off x="6542531" y="3236976"/>
-            <a:ext cx="1936241" cy="685800"/>
+            <a:off x="6542531" y="3054096"/>
+            <a:ext cx="1936241" cy="731520"/>
           </a:xfrm>
           <a:prstGeom prst="rect">
             <a:avLst/>
@@ -21209,8 +21209,8 @@
         </p:nvSpPr>
         <p:spPr>
           <a:xfrm>
-            <a:off x="9063989" y="2103120"/>
-            <a:ext cx="2558034" cy="1883664"/>
+            <a:off x="9063989" y="1920240"/>
+            <a:ext cx="2558034" cy="2011680"/>
           </a:xfrm>
           <a:prstGeom prst="roundRect">
             <a:avLst>
@@ -21243,7 +21243,7 @@
         </p:nvSpPr>
         <p:spPr>
           <a:xfrm>
-            <a:off x="9374885" y="2414015"/>
+            <a:off x="9374885" y="2231136"/>
             <a:ext cx="310896" cy="310896"/>
           </a:xfrm>
           <a:prstGeom prst="ellipse">
@@ -21270,7 +21270,7 @@
         </p:nvSpPr>
         <p:spPr>
           <a:xfrm>
-            <a:off x="9374885" y="2414015"/>
+            <a:off x="9374885" y="2231136"/>
             <a:ext cx="310896" cy="310896"/>
           </a:xfrm>
           <a:prstGeom prst="rect">
@@ -21309,7 +21309,7 @@
         </p:nvSpPr>
         <p:spPr>
           <a:xfrm>
-            <a:off x="9374885" y="2889503"/>
+            <a:off x="9374885" y="2706624"/>
             <a:ext cx="1936241" cy="292608"/>
           </a:xfrm>
           <a:prstGeom prst="rect">
@@ -21348,8 +21348,8 @@
         </p:nvSpPr>
         <p:spPr>
           <a:xfrm>
-            <a:off x="9374885" y="3236976"/>
-            <a:ext cx="1936241" cy="685800"/>
+            <a:off x="9374885" y="3054096"/>
+            <a:ext cx="1936241" cy="731520"/>
           </a:xfrm>
           <a:prstGeom prst="rect">
             <a:avLst/>
@@ -21390,8 +21390,8 @@
         </p:nvSpPr>
         <p:spPr>
           <a:xfrm>
-            <a:off x="566928" y="4370831"/>
-            <a:ext cx="2558034" cy="1883664"/>
+            <a:off x="566928" y="4206240"/>
+            <a:ext cx="2558034" cy="2011680"/>
           </a:xfrm>
           <a:prstGeom prst="roundRect">
             <a:avLst>
@@ -21424,7 +21424,7 @@
         </p:nvSpPr>
         <p:spPr>
           <a:xfrm>
-            <a:off x="877824" y="4681727"/>
+            <a:off x="877824" y="4517136"/>
             <a:ext cx="310896" cy="310896"/>
           </a:xfrm>
           <a:prstGeom prst="ellipse">
@@ -21451,7 +21451,7 @@
         </p:nvSpPr>
         <p:spPr>
           <a:xfrm>
-            <a:off x="877824" y="4681727"/>
+            <a:off x="877824" y="4517136"/>
             <a:ext cx="310896" cy="310896"/>
           </a:xfrm>
           <a:prstGeom prst="rect">
@@ -21490,7 +21490,7 @@
         </p:nvSpPr>
         <p:spPr>
           <a:xfrm>
-            <a:off x="877824" y="5157216"/>
+            <a:off x="877824" y="4992624"/>
             <a:ext cx="1936241" cy="292608"/>
           </a:xfrm>
           <a:prstGeom prst="rect">
@@ -21529,8 +21529,8 @@
         </p:nvSpPr>
         <p:spPr>
           <a:xfrm>
-            <a:off x="877824" y="5504688"/>
-            <a:ext cx="1936241" cy="685800"/>
+            <a:off x="877824" y="5340096"/>
+            <a:ext cx="1936241" cy="731520"/>
           </a:xfrm>
           <a:prstGeom prst="rect">
             <a:avLst/>
@@ -21571,8 +21571,8 @@
         </p:nvSpPr>
         <p:spPr>
           <a:xfrm>
-            <a:off x="3399282" y="4370831"/>
-            <a:ext cx="2558034" cy="1883664"/>
+            <a:off x="3399282" y="4206240"/>
+            <a:ext cx="2558034" cy="2011680"/>
           </a:xfrm>
           <a:prstGeom prst="roundRect">
             <a:avLst>
@@ -21605,7 +21605,7 @@
         </p:nvSpPr>
         <p:spPr>
           <a:xfrm>
-            <a:off x="3710178" y="4681727"/>
+            <a:off x="3710178" y="4517136"/>
             <a:ext cx="310896" cy="310896"/>
           </a:xfrm>
           <a:prstGeom prst="ellipse">
@@ -21632,7 +21632,7 @@
         </p:nvSpPr>
         <p:spPr>
           <a:xfrm>
-            <a:off x="3710178" y="4681727"/>
+            <a:off x="3710178" y="4517136"/>
             <a:ext cx="310896" cy="310896"/>
           </a:xfrm>
           <a:prstGeom prst="rect">
@@ -21671,7 +21671,7 @@
         </p:nvSpPr>
         <p:spPr>
           <a:xfrm>
-            <a:off x="3710178" y="5157216"/>
+            <a:off x="3710178" y="4992624"/>
             <a:ext cx="1936241" cy="292608"/>
           </a:xfrm>
           <a:prstGeom prst="rect">
@@ -21710,8 +21710,8 @@
         </p:nvSpPr>
         <p:spPr>
           <a:xfrm>
-            <a:off x="3710178" y="5504688"/>
-            <a:ext cx="1936241" cy="685800"/>
+            <a:off x="3710178" y="5340096"/>
+            <a:ext cx="1936241" cy="731520"/>
           </a:xfrm>
           <a:prstGeom prst="rect">
             <a:avLst/>
@@ -21752,8 +21752,8 @@
         </p:nvSpPr>
         <p:spPr>
           <a:xfrm>
-            <a:off x="6231636" y="4370831"/>
-            <a:ext cx="2558034" cy="1883664"/>
+            <a:off x="6231636" y="4206240"/>
+            <a:ext cx="2558034" cy="2011680"/>
           </a:xfrm>
           <a:prstGeom prst="roundRect">
             <a:avLst>
@@ -21786,7 +21786,7 @@
         </p:nvSpPr>
         <p:spPr>
           <a:xfrm>
-            <a:off x="6542531" y="4681727"/>
+            <a:off x="6542531" y="4517136"/>
             <a:ext cx="310896" cy="310896"/>
           </a:xfrm>
           <a:prstGeom prst="ellipse">
@@ -21813,7 +21813,7 @@
         </p:nvSpPr>
         <p:spPr>
           <a:xfrm>
-            <a:off x="6542531" y="4681727"/>
+            <a:off x="6542531" y="4517136"/>
             <a:ext cx="310896" cy="310896"/>
           </a:xfrm>
           <a:prstGeom prst="rect">
@@ -21852,7 +21852,7 @@
         </p:nvSpPr>
         <p:spPr>
           <a:xfrm>
-            <a:off x="6542531" y="5157216"/>
+            <a:off x="6542531" y="4992624"/>
             <a:ext cx="1936241" cy="292608"/>
           </a:xfrm>
           <a:prstGeom prst="rect">
@@ -21891,8 +21891,8 @@
         </p:nvSpPr>
         <p:spPr>
           <a:xfrm>
-            <a:off x="6542531" y="5504688"/>
-            <a:ext cx="1936241" cy="685800"/>
+            <a:off x="6542531" y="5340096"/>
+            <a:ext cx="1936241" cy="731520"/>
           </a:xfrm>
           <a:prstGeom prst="rect">
             <a:avLst/>

</xml_diff>